<commit_message>
Level 5 Lesson 5 draft listening audio (1:43)
</commit_message>
<xml_diff>
--- a/level5/slides/Level5_Lesson5_Slides.pptx
+++ b/level5/slides/Level5_Lesson5_Slides.pptx
@@ -8,32 +8,32 @@
     <p:notesMasterId r:id="rId22"/>
   </p:notesMasterIdLst>
   <p:sldIdLst>
-    <p:sldId id="939" r:id="rId33"/>
-    <p:sldId id="940" r:id="rId34"/>
-    <p:sldId id="941" r:id="rId35"/>
-    <p:sldId id="942" r:id="rId36"/>
-    <p:sldId id="943" r:id="rId31"/>
-    <p:sldId id="944" r:id="rId30"/>
-    <p:sldId id="945" r:id="rId29"/>
-    <p:sldId id="946" r:id="rId28"/>
-    <p:sldId id="947" r:id="rId27"/>
-    <p:sldId id="948" r:id="rId20"/>
-    <p:sldId id="949" r:id="rId18"/>
-    <p:sldId id="950" r:id="rId17"/>
-    <p:sldId id="951" r:id="rId16"/>
-    <p:sldId id="952" r:id="rId14"/>
-    <p:sldId id="953" r:id="rId13"/>
-    <p:sldId id="954" r:id="rId12"/>
-    <p:sldId id="955" r:id="rId11"/>
-    <p:sldId id="956" r:id="rId10"/>
-    <p:sldId id="957" r:id="rId8"/>
-    <p:sldId id="958" r:id="rId7"/>
-    <p:sldId id="959" r:id="rId6"/>
-    <p:sldId id="960" r:id="rId5"/>
-    <p:sldId id="961" r:id="rId4"/>
-    <p:sldId id="962" r:id="rId3"/>
-    <p:sldId id="963" r:id="rId57"/>
-    <p:sldId id="964" r:id="rId2"/>
+    <p:sldId id="1017" r:id="rId32"/>
+    <p:sldId id="1018" r:id="rId21"/>
+    <p:sldId id="1019" r:id="rId19"/>
+    <p:sldId id="1020" r:id="rId15"/>
+    <p:sldId id="1021" r:id="rId37"/>
+    <p:sldId id="1022" r:id="rId38"/>
+    <p:sldId id="1023" r:id="rId39"/>
+    <p:sldId id="1024" r:id="rId40"/>
+    <p:sldId id="1025" r:id="rId41"/>
+    <p:sldId id="1026" r:id="rId42"/>
+    <p:sldId id="1027" r:id="rId43"/>
+    <p:sldId id="1028" r:id="rId44"/>
+    <p:sldId id="1029" r:id="rId45"/>
+    <p:sldId id="1030" r:id="rId46"/>
+    <p:sldId id="1031" r:id="rId47"/>
+    <p:sldId id="1032" r:id="rId48"/>
+    <p:sldId id="1033" r:id="rId49"/>
+    <p:sldId id="1034" r:id="rId50"/>
+    <p:sldId id="1035" r:id="rId51"/>
+    <p:sldId id="1036" r:id="rId52"/>
+    <p:sldId id="1037" r:id="rId53"/>
+    <p:sldId id="1038" r:id="rId54"/>
+    <p:sldId id="1039" r:id="rId55"/>
+    <p:sldId id="1040" r:id="rId56"/>
+    <p:sldId id="1041" r:id="rId9"/>
+    <p:sldId id="1042" r:id="rId58"/>
   </p:sldIdLst>
   <p:sldSz cx="12192000" cy="6858000"/>
   <p:notesSz cx="6858000" cy="12192000"/>
@@ -481,7 +481,7 @@
 </p:notesMaster>
 </file>
 
-<file path=ppt/notesSlides/notesSlide1.xml><?xml version="1.0" encoding="utf-8"?>
+<file path=ppt/notesSlides/notesSlide14.xml><?xml version="1.0" encoding="utf-8"?>
 <p:notes xmlns:a="http://schemas.openxmlformats.org/drawingml/2006/main" xmlns:p="http://schemas.openxmlformats.org/presentationml/2006/main" xmlns:r="http://schemas.openxmlformats.org/officeDocument/2006/relationships">
   <p:cSld>
     <p:spTree>
@@ -526,27 +526,17 @@
           <a:lstStyle/>
           <a:p>
             <a:r>
-              <a:t>Credits. You don't need to read this slide in class.</a:t>
-            </a:r>
-          </a:p>
-          <a:p>
-            <a:r>
-              <a:t>Pictures: Twemoji graphics by Twitter, Inc. and other contributors, CC BY 4.0; the file-by-file list is in images/CREDITS.md.</a:t>
-            </a:r>
-          </a:p>
-          <a:p>
-            <a:r>
-              <a:t>Audio: the listening audio for this lesson (about 2:20) is coming soon. It will use computer-generated voices (Chatterbox TTS cloned from synthetic Kokoro-82M reference clips); no recordings of real people. Until it is ready, read the listening script (in the notes of the Before You Listen slide) with a volunteer. The names and the story are invented.</a:t>
-            </a:r>
-          </a:p>
-          <a:p>
-            <a:r>
-              <a:t>Course materials: © 2026 the authors, licensed under CC BY-NC-SA 4.0 (https://creativecommons.org/licenses/by-nc-sa/4.0/).</a:t>
-            </a:r>
-          </a:p>
-          <a:p>
-            <a:r>
-              <a:t>Lesson plan: Picture Credits. Picture list: images/CREDITS.md.</a:t>
+              <a:t>Each click shows the next card.</a:t>
+            </a:r>
+          </a:p>
+          <a:p>
+            <a:r>
+              <a:t>A asks. B answers. Then switch.</a:t>
+            </a:r>
+          </a:p>
+          <a:p>
+            <a:r>
+              <a:t>Lesson plan: Step 1; Opening Talk page.</a:t>
             </a:r>
           </a:p>
         </p:txBody>
@@ -571,7 +561,7 @@
 </p:notes>
 </file>
 
-<file path=ppt/notesSlides/notesSlide10.xml><?xml version="1.0" encoding="utf-8"?>
+<file path=ppt/notesSlides/notesSlide18.xml><?xml version="1.0" encoding="utf-8"?>
 <p:notes xmlns:a="http://schemas.openxmlformats.org/drawingml/2006/main" xmlns:p="http://schemas.openxmlformats.org/presentationml/2006/main" xmlns:r="http://schemas.openxmlformats.org/officeDocument/2006/relationships">
   <p:cSld>
     <p:spTree>
@@ -616,12 +606,22 @@
           <a:lstStyle/>
           <a:p>
             <a:r>
-              <a:t>Click to show each answer: 1 added • 2 received • 3 posted • 4 mailed • 5 listed • 6 high</a:t>
-            </a:r>
-          </a:p>
-          <a:p>
-            <a:r>
-              <a:t>Lesson plan: Step 4; Grammar Practice A; Answer key.</a:t>
+              <a:t>Step 1 · 6:00–6:06 · Opening Talk.</a:t>
+            </a:r>
+          </a:p>
+          <a:p>
+            <a:r>
+              <a:t>Work with a partner.</a:t>
+            </a:r>
+          </a:p>
+          <a:p>
+            <a:r>
+              <a:t>Lesson plan: Step 1; Opening Talk page.</a:t>
+            </a:r>
+          </a:p>
+          <a:p>
+            <a:r>
+              <a:t>Picture: Twemoji graphics by Twitter, Inc. and other contributors (https://github.com/jdecked/twemoji), CC BY 4.0 (https://creativecommons.org/licenses/by/4.0/); resized and combined, with signs and labels (images/CREDITS.md).</a:t>
             </a:r>
           </a:p>
         </p:txBody>
@@ -646,7 +646,7 @@
 </p:notes>
 </file>
 
-<file path=ppt/notesSlides/notesSlide11.xml><?xml version="1.0" encoding="utf-8"?>
+<file path=ppt/notesSlides/notesSlide20.xml><?xml version="1.0" encoding="utf-8"?>
 <p:notes xmlns:a="http://schemas.openxmlformats.org/drawingml/2006/main" xmlns:p="http://schemas.openxmlformats.org/presentationml/2006/main" xmlns:r="http://schemas.openxmlformats.org/officeDocument/2006/relationships">
   <p:cSld>
     <p:spTree>
@@ -691,17 +691,12 @@
           <a:lstStyle/>
           <a:p>
             <a:r>
-              <a:t>Grammar Box 4: start with the thing. Each click shows the answer side.</a:t>
-            </a:r>
-          </a:p>
-          <a:p>
-            <a:r>
-              <a:t>Lesson plan: Step 4; Grammar Box 4.</a:t>
-            </a:r>
-          </a:p>
-          <a:p>
-            <a:r>
-              <a:t>Picture: Twemoji graphics by Twitter, Inc. and other contributors (https://github.com/jdecked/twemoji), CC BY 4.0 (https://creativecommons.org/licenses/by/4.0/); resized and combined, with signs and labels (images/CREDITS.md).</a:t>
+              <a:t>Read each goal slowly. Learners repeat.</a:t>
+            </a:r>
+          </a:p>
+          <a:p>
+            <a:r>
+              <a:t>Lesson plan: At a glance: Objectives.</a:t>
             </a:r>
           </a:p>
         </p:txBody>
@@ -726,7 +721,7 @@
 </p:notes>
 </file>
 
-<file path=ppt/notesSlides/notesSlide12.xml><?xml version="1.0" encoding="utf-8"?>
+<file path=ppt/notesSlides/notesSlide26.xml><?xml version="1.0" encoding="utf-8"?>
 <p:notes xmlns:a="http://schemas.openxmlformats.org/drawingml/2006/main" xmlns:p="http://schemas.openxmlformats.org/presentationml/2006/main" xmlns:r="http://schemas.openxmlformats.org/officeDocument/2006/relationships">
   <p:cSld>
     <p:spTree>
@@ -771,12 +766,22 @@
           <a:lstStyle/>
           <a:p>
             <a:r>
-              <a:t>Grammar Box 3: yes and no. Each click shows the answer side.</a:t>
-            </a:r>
-          </a:p>
-          <a:p>
-            <a:r>
-              <a:t>Lesson plan: Step 4; Grammar Box 3.</a:t>
+              <a:t>Welcome learners as they arrive.</a:t>
+            </a:r>
+          </a:p>
+          <a:p>
+            <a:r>
+              <a:t>Read the three lines under Today you will.</a:t>
+            </a:r>
+          </a:p>
+          <a:p>
+            <a:r>
+              <a:t>This lesson is not financial advice.</a:t>
+            </a:r>
+          </a:p>
+          <a:p>
+            <a:r>
+              <a:t>Lesson plan: Topic; At a glance: Objectives.</a:t>
             </a:r>
           </a:p>
           <a:p>
@@ -806,7 +811,7 @@
 </p:notes>
 </file>
 
-<file path=ppt/notesSlides/notesSlide13.xml><?xml version="1.0" encoding="utf-8"?>
+<file path=ppt/notesSlides/notesSlide31.xml><?xml version="1.0" encoding="utf-8"?>
 <p:notes xmlns:a="http://schemas.openxmlformats.org/drawingml/2006/main" xmlns:p="http://schemas.openxmlformats.org/presentationml/2006/main" xmlns:r="http://schemas.openxmlformats.org/officeDocument/2006/relationships">
   <p:cSld>
     <p:spTree>
@@ -851,17 +856,22 @@
           <a:lstStyle/>
           <a:p>
             <a:r>
-              <a:t>Grammar Box 2: add by when you need the name. Each click shows the answer side.</a:t>
-            </a:r>
-          </a:p>
-          <a:p>
-            <a:r>
-              <a:t>Lesson plan: Step 4; Grammar Box 2.</a:t>
-            </a:r>
-          </a:p>
-          <a:p>
-            <a:r>
-              <a:t>Picture: Twemoji graphics by Twitter, Inc. and other contributors (https://github.com/jdecked/twemoji), CC BY 4.0 (https://creativecommons.org/licenses/by/4.0/); resized and combined, with signs and labels (images/CREDITS.md).</a:t>
+              <a:t>Step 2 · 6:06–6:12 · New Words.</a:t>
+            </a:r>
+          </a:p>
+          <a:p>
+            <a:r>
+              <a:t>Point to each picture. Learners repeat. ★ = most important.</a:t>
+            </a:r>
+          </a:p>
+          <a:p>
+            <a:r>
+              <a:t>Lesson plan: Step 2; New Words page.</a:t>
+            </a:r>
+          </a:p>
+          <a:p>
+            <a:r>
+              <a:t>Pictures: Twemoji graphics by Twitter, Inc. and other contributors (https://github.com/jdecked/twemoji), CC BY 4.0 (https://creativecommons.org/licenses/by/4.0/); resized and combined, with signs and labels (images/CREDITS.md).</a:t>
             </a:r>
           </a:p>
         </p:txBody>
@@ -886,7 +896,7 @@
 </p:notes>
 </file>
 
-<file path=ppt/notesSlides/notesSlide15.xml><?xml version="1.0" encoding="utf-8"?>
+<file path=ppt/notesSlides/notesSlide32.xml><?xml version="1.0" encoding="utf-8"?>
 <p:notes xmlns:a="http://schemas.openxmlformats.org/drawingml/2006/main" xmlns:p="http://schemas.openxmlformats.org/presentationml/2006/main" xmlns:r="http://schemas.openxmlformats.org/officeDocument/2006/relationships">
   <p:cSld>
     <p:spTree>
@@ -931,17 +941,17 @@
           <a:lstStyle/>
           <a:p>
             <a:r>
-              <a:t>Grammar Box 1: is, are, was, were. Each click shows the answer side.</a:t>
-            </a:r>
-          </a:p>
-          <a:p>
-            <a:r>
-              <a:t>Lesson plan: Step 4; Grammar Box 1.</a:t>
-            </a:r>
-          </a:p>
-          <a:p>
-            <a:r>
-              <a:t>Picture: Twemoji graphics by Twitter, Inc. and other contributors (https://github.com/jdecked/twemoji), CC BY 4.0 (https://creativecommons.org/licenses/by/4.0/); resized and combined, with signs and labels (images/CREDITS.md).</a:t>
+              <a:t>A points to a picture. B names it and uses it in one sentence. Then switch.</a:t>
+            </a:r>
+          </a:p>
+          <a:p>
+            <a:r>
+              <a:t>Lesson plan: Step 2; New Words page; Partner game.</a:t>
+            </a:r>
+          </a:p>
+          <a:p>
+            <a:r>
+              <a:t>Pictures: Twemoji graphics by Twitter, Inc. and other contributors (https://github.com/jdecked/twemoji), CC BY 4.0 (https://creativecommons.org/licenses/by/4.0/); resized and combined, with signs and labels (images/CREDITS.md).</a:t>
             </a:r>
           </a:p>
         </p:txBody>
@@ -966,7 +976,7 @@
 </p:notes>
 </file>
 
-<file path=ppt/notesSlides/notesSlide16.xml><?xml version="1.0" encoding="utf-8"?>
+<file path=ppt/notesSlides/notesSlide33.xml><?xml version="1.0" encoding="utf-8"?>
 <p:notes xmlns:a="http://schemas.openxmlformats.org/drawingml/2006/main" xmlns:p="http://schemas.openxmlformats.org/presentationml/2006/main" xmlns:r="http://schemas.openxmlformats.org/officeDocument/2006/relationships">
   <p:cSld>
     <p:spTree>
@@ -1011,12 +1021,32 @@
           <a:lstStyle/>
           <a:p>
             <a:r>
-              <a:t>gonna and wanna are short forms. This listening uses the full forms. Say each line two times.</a:t>
-            </a:r>
-          </a:p>
-          <a:p>
-            <a:r>
-              <a:t>Lesson plan: Step 3: Hear it, say it.</a:t>
+              <a:t>The answers are hidden. Ask, then click.</a:t>
+            </a:r>
+          </a:p>
+          <a:p>
+            <a:r>
+              <a:t>1. yes</a:t>
+            </a:r>
+          </a:p>
+          <a:p>
+            <a:r>
+              <a:t>2. a receipt</a:t>
+            </a:r>
+          </a:p>
+          <a:p>
+            <a:r>
+              <a:t>3. credit</a:t>
+            </a:r>
+          </a:p>
+          <a:p>
+            <a:r>
+              <a:t>Lesson plan: Step 2: Check the Meaning.</a:t>
+            </a:r>
+          </a:p>
+          <a:p>
+            <a:r>
+              <a:t>Pictures: Twemoji graphics by Twitter, Inc. and other contributors (https://github.com/jdecked/twemoji), CC BY 4.0 (https://creativecommons.org/licenses/by/4.0/); resized and combined, with signs and labels (images/CREDITS.md).</a:t>
             </a:r>
           </a:p>
         </p:txBody>
@@ -1041,7 +1071,7 @@
 </p:notes>
 </file>
 
-<file path=ppt/notesSlides/notesSlide17.xml><?xml version="1.0" encoding="utf-8"?>
+<file path=ppt/notesSlides/notesSlide34.xml><?xml version="1.0" encoding="utf-8"?>
 <p:notes xmlns:a="http://schemas.openxmlformats.org/drawingml/2006/main" xmlns:p="http://schemas.openxmlformats.org/presentationml/2006/main" xmlns:r="http://schemas.openxmlformats.org/officeDocument/2006/relationships">
   <p:cSld>
     <p:spTree>
@@ -1086,12 +1116,27 @@
           <a:lstStyle/>
           <a:p>
             <a:r>
-              <a:t>Click to show each answer: 1 was added • 2 was received • 3 was posted • 4 is mailed • 5 are listed • 6 wasn't removed</a:t>
-            </a:r>
-          </a:p>
-          <a:p>
-            <a:r>
-              <a:t>Lesson plan: Step 3; Listening Task C; Answer key.</a:t>
+              <a:t>Step 3 · 6:12–6:32 · Listening. Play 1 is Task A. Play 2 is Tasks B and C. A third play is fine.</a:t>
+            </a:r>
+          </a:p>
+          <a:p>
+            <a:r>
+              <a:t>Diego calls customer service about a statement.</a:t>
+            </a:r>
+          </a:p>
+          <a:p>
+            <a:r>
+              <a:t>The script says going to and want to. Learners only need to recognize gonna and wanna.</a:t>
+            </a:r>
+          </a:p>
+          <a:p>
+            <a:r>
+              <a:t>Lesson plan: Step 3; Listening page.</a:t>
+            </a:r>
+          </a:p>
+          <a:p>
+            <a:r>
+              <a:t>Picture: Twemoji graphics by Twitter, Inc. and other contributors (https://github.com/jdecked/twemoji), CC BY 4.0 (https://creativecommons.org/licenses/by/4.0/); resized and combined, with signs and labels (images/CREDITS.md).</a:t>
             </a:r>
           </a:p>
         </p:txBody>
@@ -1116,7 +1161,7 @@
 </p:notes>
 </file>
 
-<file path=ppt/notesSlides/notesSlide19.xml><?xml version="1.0" encoding="utf-8"?>
+<file path=ppt/notesSlides/notesSlide35.xml><?xml version="1.0" encoding="utf-8"?>
 <p:notes xmlns:a="http://schemas.openxmlformats.org/drawingml/2006/main" xmlns:p="http://schemas.openxmlformats.org/presentationml/2006/main" xmlns:r="http://schemas.openxmlformats.org/officeDocument/2006/relationships">
   <p:cSld>
     <p:spTree>
@@ -1161,12 +1206,12 @@
           <a:lstStyle/>
           <a:p>
             <a:r>
-              <a:t>Click to circle each answer: 1 on Tuesday • 2 on Friday • 3 $6 • 4 money back • 5 $0</a:t>
-            </a:r>
-          </a:p>
-          <a:p>
-            <a:r>
-              <a:t>Lesson plan: Step 3; Listening Task B; Answer key.</a:t>
+              <a:t>Click to circle b.</a:t>
+            </a:r>
+          </a:p>
+          <a:p>
+            <a:r>
+              <a:t>Lesson plan: Step 3; Listening Task A; Answer key.</a:t>
             </a:r>
           </a:p>
         </p:txBody>
@@ -1191,7 +1236,7 @@
 </p:notes>
 </file>
 
-<file path=ppt/notesSlides/notesSlide2.xml><?xml version="1.0" encoding="utf-8"?>
+<file path=ppt/notesSlides/notesSlide36.xml><?xml version="1.0" encoding="utf-8"?>
 <p:notes xmlns:a="http://schemas.openxmlformats.org/drawingml/2006/main" xmlns:p="http://schemas.openxmlformats.org/presentationml/2006/main" xmlns:r="http://schemas.openxmlformats.org/officeDocument/2006/relationships">
   <p:cSld>
     <p:spTree>
@@ -1236,22 +1281,12 @@
           <a:lstStyle/>
           <a:p>
             <a:r>
-              <a:t>Step 7 · 7:25–7:30 · Exit ticket and homework. Never skip the exit ticket.</a:t>
-            </a:r>
-          </a:p>
-          <a:p>
-            <a:r>
-              <a:t>Explain one line from a statement.</a:t>
-            </a:r>
-          </a:p>
-          <a:p>
-            <a:r>
-              <a:t>Lesson plan: Step 7; Exit Ticket page; Homework page.</a:t>
-            </a:r>
-          </a:p>
-          <a:p>
-            <a:r>
-              <a:t>Picture: Twemoji graphics by Twitter, Inc. and other contributors (https://github.com/jdecked/twemoji), CC BY 4.0 (https://creativecommons.org/licenses/by/4.0/); resized and combined, with signs and labels (images/CREDITS.md).</a:t>
+              <a:t>Click to circle each answer: 1 on Tuesday • 2 on Friday • 3 $6 • 4 money back • 5 $0</a:t>
+            </a:r>
+          </a:p>
+          <a:p>
+            <a:r>
+              <a:t>Lesson plan: Step 3; Listening Task B; Answer key.</a:t>
             </a:r>
           </a:p>
         </p:txBody>
@@ -1276,7 +1311,7 @@
 </p:notes>
 </file>
 
-<file path=ppt/notesSlides/notesSlide21.xml><?xml version="1.0" encoding="utf-8"?>
+<file path=ppt/notesSlides/notesSlide37.xml><?xml version="1.0" encoding="utf-8"?>
 <p:notes xmlns:a="http://schemas.openxmlformats.org/drawingml/2006/main" xmlns:p="http://schemas.openxmlformats.org/presentationml/2006/main" xmlns:r="http://schemas.openxmlformats.org/officeDocument/2006/relationships">
   <p:cSld>
     <p:spTree>
@@ -1321,12 +1356,12 @@
           <a:lstStyle/>
           <a:p>
             <a:r>
-              <a:t>Click to circle b.</a:t>
-            </a:r>
-          </a:p>
-          <a:p>
-            <a:r>
-              <a:t>Lesson plan: Step 3; Listening Task A; Answer key.</a:t>
+              <a:t>Click to show each answer: 1 was added • 2 was received • 3 was posted • 4 is mailed • 5 are listed • 6 wasn't removed</a:t>
+            </a:r>
+          </a:p>
+          <a:p>
+            <a:r>
+              <a:t>Lesson plan: Step 3; Listening Task C; Answer key.</a:t>
             </a:r>
           </a:p>
         </p:txBody>
@@ -1351,7 +1386,7 @@
 </p:notes>
 </file>
 
-<file path=ppt/notesSlides/notesSlide22.xml><?xml version="1.0" encoding="utf-8"?>
+<file path=ppt/notesSlides/notesSlide38.xml><?xml version="1.0" encoding="utf-8"?>
 <p:notes xmlns:a="http://schemas.openxmlformats.org/drawingml/2006/main" xmlns:p="http://schemas.openxmlformats.org/presentationml/2006/main" xmlns:r="http://schemas.openxmlformats.org/officeDocument/2006/relationships">
   <p:cSld>
     <p:spTree>
@@ -1396,117 +1431,12 @@
           <a:lstStyle/>
           <a:p>
             <a:r>
-              <a:t>Step 3 · 6:12–6:32 · Listening. Play 1 is Task A. Play 2 is Tasks B and C. A third play is fine.</a:t>
-            </a:r>
-          </a:p>
-          <a:p>
-            <a:r>
-              <a:t>Diego calls customer service about a statement.</a:t>
-            </a:r>
-          </a:p>
-          <a:p>
-            <a:r>
-              <a:t>The script says going to and want to. Learners only need to recognize gonna and wanna.</a:t>
-            </a:r>
-          </a:p>
-          <a:p>
-            <a:r>
-              <a:t>Lesson plan: Step 3; Listening page.</a:t>
-            </a:r>
-          </a:p>
-          <a:p>
-            <a:r>
-              <a:t>Picture: Twemoji graphics by Twitter, Inc. and other contributors (https://github.com/jdecked/twemoji), CC BY 4.0 (https://creativecommons.org/licenses/by/4.0/); resized and combined, with signs and labels (images/CREDITS.md).</a:t>
-            </a:r>
-          </a:p>
-          <a:p>
-            <a:r>
-              <a:t>Listening script (the audio is coming soon; until then, read it aloud with a volunteer at a normal, friendly speed):</a:t>
-            </a:r>
-          </a:p>
-          <a:p>
-            <a:r>
-              <a:t>Narrator: Lesson five. Diego calls Northline Phone about a practice statement. Nothing on this call is a real bill.</a:t>
-            </a:r>
-          </a:p>
-          <a:p>
-            <a:r>
-              <a:t>Diego: Hello. I want to understand my statement. A fee was added, and I am going to ask about it.</a:t>
-            </a:r>
-          </a:p>
-          <a:p>
-            <a:r>
-              <a:t>Ms. Brooks: I can help. The fee was added on Tuesday. The fee was $6.</a:t>
-            </a:r>
-          </a:p>
-          <a:p>
-            <a:r>
-              <a:t>Diego: Was the payment received?</a:t>
-            </a:r>
-          </a:p>
-          <a:p>
-            <a:r>
-              <a:t>Ms. Brooks: Yes, it was. The payment was received on Friday. It was $40.</a:t>
-            </a:r>
-          </a:p>
-          <a:p>
-            <a:r>
-              <a:t>Diego: And the credit? I want to know what that word means.</a:t>
-            </a:r>
-          </a:p>
-          <a:p>
-            <a:r>
-              <a:t>Ms. Brooks: The credit was posted by the phone company. Credit means money back. It is not a new phone.</a:t>
-            </a:r>
-          </a:p>
-          <a:p>
-            <a:r>
-              <a:t>Diego: Was the fee removed?</a:t>
-            </a:r>
-          </a:p>
-          <a:p>
-            <a:r>
-              <a:t>Ms. Brooks: No, it wasn't. The $6 was credited. That is the money back.</a:t>
-            </a:r>
-          </a:p>
-          <a:p>
-            <a:r>
-              <a:t>Diego: Are the calls listed?</a:t>
-            </a:r>
-          </a:p>
-          <a:p>
-            <a:r>
-              <a:t>Ms. Brooks: Yes, they are. They are listed on page 2. The bill is mailed on the first of the month.</a:t>
-            </a:r>
-          </a:p>
-          <a:p>
-            <a:r>
-              <a:t>Diego: What is due today?</a:t>
-            </a:r>
-          </a:p>
-          <a:p>
-            <a:r>
-              <a:t>Ms. Brooks: Nothing is due today. Due today is $0. The due date on the statement is the 20th.</a:t>
-            </a:r>
-          </a:p>
-          <a:p>
-            <a:r>
-              <a:t>Diego: Thank you. I am going to read the due date again at home. The balance is $28.</a:t>
-            </a:r>
-          </a:p>
-          <a:p>
-            <a:r>
-              <a:t>Ms. Brooks: That is right. For a real charge, call the number on your own statement. This call is practice.</a:t>
-            </a:r>
-          </a:p>
-          <a:p>
-            <a:r>
-              <a:t>Narrator: Diego writes two lines: the fee was added on Tuesday, and the payment was received on Friday.</a:t>
-            </a:r>
-          </a:p>
-          <a:p>
-            <a:r>
-              <a:t>Narrator: That's the end of the listening.</a:t>
+              <a:t>gonna and wanna are short forms. This listening uses the full forms. Say each line two times.</a:t>
+            </a:r>
+          </a:p>
+          <a:p>
+            <a:r>
+              <a:t>Lesson plan: Step 3: Hear it, say it.</a:t>
             </a:r>
           </a:p>
         </p:txBody>
@@ -1531,7 +1461,7 @@
 </p:notes>
 </file>
 
-<file path=ppt/notesSlides/notesSlide23.xml><?xml version="1.0" encoding="utf-8"?>
+<file path=ppt/notesSlides/notesSlide39.xml><?xml version="1.0" encoding="utf-8"?>
 <p:notes xmlns:a="http://schemas.openxmlformats.org/drawingml/2006/main" xmlns:p="http://schemas.openxmlformats.org/presentationml/2006/main" xmlns:r="http://schemas.openxmlformats.org/officeDocument/2006/relationships">
   <p:cSld>
     <p:spTree>
@@ -1576,32 +1506,17 @@
           <a:lstStyle/>
           <a:p>
             <a:r>
-              <a:t>The answers are hidden. Ask, then click.</a:t>
-            </a:r>
-          </a:p>
-          <a:p>
-            <a:r>
-              <a:t>1. yes</a:t>
-            </a:r>
-          </a:p>
-          <a:p>
-            <a:r>
-              <a:t>2. a receipt</a:t>
-            </a:r>
-          </a:p>
-          <a:p>
-            <a:r>
-              <a:t>3. credit</a:t>
-            </a:r>
-          </a:p>
-          <a:p>
-            <a:r>
-              <a:t>Lesson plan: Step 2: Check the Meaning.</a:t>
-            </a:r>
-          </a:p>
-          <a:p>
-            <a:r>
-              <a:t>Pictures: Twemoji graphics by Twitter, Inc. and other contributors (https://github.com/jdecked/twemoji), CC BY 4.0 (https://creativecommons.org/licenses/by/4.0/); resized and combined, with signs and labels (images/CREDITS.md).</a:t>
+              <a:t>Grammar Box 1: is, are, was, were. Each click shows the answer side.</a:t>
+            </a:r>
+          </a:p>
+          <a:p>
+            <a:r>
+              <a:t>Lesson plan: Step 4; Grammar Box 1.</a:t>
+            </a:r>
+          </a:p>
+          <a:p>
+            <a:r>
+              <a:t>Picture: Twemoji graphics by Twitter, Inc. and other contributors (https://github.com/jdecked/twemoji), CC BY 4.0 (https://creativecommons.org/licenses/by/4.0/); resized and combined, with signs and labels (images/CREDITS.md).</a:t>
             </a:r>
           </a:p>
         </p:txBody>
@@ -1626,7 +1541,7 @@
 </p:notes>
 </file>
 
-<file path=ppt/notesSlides/notesSlide24.xml><?xml version="1.0" encoding="utf-8"?>
+<file path=ppt/notesSlides/notesSlide40.xml><?xml version="1.0" encoding="utf-8"?>
 <p:notes xmlns:a="http://schemas.openxmlformats.org/drawingml/2006/main" xmlns:p="http://schemas.openxmlformats.org/presentationml/2006/main" xmlns:r="http://schemas.openxmlformats.org/officeDocument/2006/relationships">
   <p:cSld>
     <p:spTree>
@@ -1671,17 +1586,17 @@
           <a:lstStyle/>
           <a:p>
             <a:r>
-              <a:t>A points to a picture. B names it and uses it in one sentence. Then switch.</a:t>
-            </a:r>
-          </a:p>
-          <a:p>
-            <a:r>
-              <a:t>Lesson plan: Step 2; New Words page; Partner game.</a:t>
-            </a:r>
-          </a:p>
-          <a:p>
-            <a:r>
-              <a:t>Pictures: Twemoji graphics by Twitter, Inc. and other contributors (https://github.com/jdecked/twemoji), CC BY 4.0 (https://creativecommons.org/licenses/by/4.0/); resized and combined, with signs and labels (images/CREDITS.md).</a:t>
+              <a:t>Grammar Box 2: add by when you need the name. Each click shows the answer side.</a:t>
+            </a:r>
+          </a:p>
+          <a:p>
+            <a:r>
+              <a:t>Lesson plan: Step 4; Grammar Box 2.</a:t>
+            </a:r>
+          </a:p>
+          <a:p>
+            <a:r>
+              <a:t>Picture: Twemoji graphics by Twitter, Inc. and other contributors (https://github.com/jdecked/twemoji), CC BY 4.0 (https://creativecommons.org/licenses/by/4.0/); resized and combined, with signs and labels (images/CREDITS.md).</a:t>
             </a:r>
           </a:p>
         </p:txBody>
@@ -1706,7 +1621,7 @@
 </p:notes>
 </file>
 
-<file path=ppt/notesSlides/notesSlide25.xml><?xml version="1.0" encoding="utf-8"?>
+<file path=ppt/notesSlides/notesSlide41.xml><?xml version="1.0" encoding="utf-8"?>
 <p:notes xmlns:a="http://schemas.openxmlformats.org/drawingml/2006/main" xmlns:p="http://schemas.openxmlformats.org/presentationml/2006/main" xmlns:r="http://schemas.openxmlformats.org/officeDocument/2006/relationships">
   <p:cSld>
     <p:spTree>
@@ -1751,22 +1666,17 @@
           <a:lstStyle/>
           <a:p>
             <a:r>
-              <a:t>Step 2 · 6:06–6:12 · New Words.</a:t>
-            </a:r>
-          </a:p>
-          <a:p>
-            <a:r>
-              <a:t>Point to each picture. Learners repeat. ★ = most important.</a:t>
-            </a:r>
-          </a:p>
-          <a:p>
-            <a:r>
-              <a:t>Lesson plan: Step 2; New Words page.</a:t>
-            </a:r>
-          </a:p>
-          <a:p>
-            <a:r>
-              <a:t>Pictures: Twemoji graphics by Twitter, Inc. and other contributors (https://github.com/jdecked/twemoji), CC BY 4.0 (https://creativecommons.org/licenses/by/4.0/); resized and combined, with signs and labels (images/CREDITS.md).</a:t>
+              <a:t>Grammar Box 3: yes and no. Each click shows the answer side.</a:t>
+            </a:r>
+          </a:p>
+          <a:p>
+            <a:r>
+              <a:t>Lesson plan: Step 4; Grammar Box 3.</a:t>
+            </a:r>
+          </a:p>
+          <a:p>
+            <a:r>
+              <a:t>Picture: Twemoji graphics by Twitter, Inc. and other contributors (https://github.com/jdecked/twemoji), CC BY 4.0 (https://creativecommons.org/licenses/by/4.0/); resized and combined, with signs and labels (images/CREDITS.md).</a:t>
             </a:r>
           </a:p>
         </p:txBody>
@@ -1791,7 +1701,7 @@
 </p:notes>
 </file>
 
-<file path=ppt/notesSlides/notesSlide27.xml><?xml version="1.0" encoding="utf-8"?>
+<file path=ppt/notesSlides/notesSlide42.xml><?xml version="1.0" encoding="utf-8"?>
 <p:notes xmlns:a="http://schemas.openxmlformats.org/drawingml/2006/main" xmlns:p="http://schemas.openxmlformats.org/presentationml/2006/main" xmlns:r="http://schemas.openxmlformats.org/officeDocument/2006/relationships">
   <p:cSld>
     <p:spTree>
@@ -1836,22 +1746,12 @@
           <a:lstStyle/>
           <a:p>
             <a:r>
-              <a:t>Welcome learners as they arrive.</a:t>
-            </a:r>
-          </a:p>
-          <a:p>
-            <a:r>
-              <a:t>Read the three lines under Today you will.</a:t>
-            </a:r>
-          </a:p>
-          <a:p>
-            <a:r>
-              <a:t>This lesson is not financial advice.</a:t>
-            </a:r>
-          </a:p>
-          <a:p>
-            <a:r>
-              <a:t>Lesson plan: Topic; At a glance: Objectives.</a:t>
+              <a:t>Grammar Box 4: start with the thing. Each click shows the answer side.</a:t>
+            </a:r>
+          </a:p>
+          <a:p>
+            <a:r>
+              <a:t>Lesson plan: Step 4; Grammar Box 4.</a:t>
             </a:r>
           </a:p>
           <a:p>
@@ -1881,7 +1781,7 @@
 </p:notes>
 </file>
 
-<file path=ppt/notesSlides/notesSlide28.xml><?xml version="1.0" encoding="utf-8"?>
+<file path=ppt/notesSlides/notesSlide43.xml><?xml version="1.0" encoding="utf-8"?>
 <p:notes xmlns:a="http://schemas.openxmlformats.org/drawingml/2006/main" xmlns:p="http://schemas.openxmlformats.org/presentationml/2006/main" xmlns:r="http://schemas.openxmlformats.org/officeDocument/2006/relationships">
   <p:cSld>
     <p:spTree>
@@ -1926,12 +1826,12 @@
           <a:lstStyle/>
           <a:p>
             <a:r>
-              <a:t>Read each goal slowly. Learners repeat.</a:t>
-            </a:r>
-          </a:p>
-          <a:p>
-            <a:r>
-              <a:t>Lesson plan: At a glance: Objectives.</a:t>
+              <a:t>Click to show each answer: 1 added • 2 received • 3 posted • 4 mailed • 5 listed • 6 high</a:t>
+            </a:r>
+          </a:p>
+          <a:p>
+            <a:r>
+              <a:t>Lesson plan: Step 4; Grammar Practice A; Answer key.</a:t>
             </a:r>
           </a:p>
         </p:txBody>
@@ -1956,7 +1856,7 @@
 </p:notes>
 </file>
 
-<file path=ppt/notesSlides/notesSlide29.xml><?xml version="1.0" encoding="utf-8"?>
+<file path=ppt/notesSlides/notesSlide44.xml><?xml version="1.0" encoding="utf-8"?>
 <p:notes xmlns:a="http://schemas.openxmlformats.org/drawingml/2006/main" xmlns:p="http://schemas.openxmlformats.org/presentationml/2006/main" xmlns:r="http://schemas.openxmlformats.org/officeDocument/2006/relationships">
   <p:cSld>
     <p:spTree>
@@ -2001,22 +1901,12 @@
           <a:lstStyle/>
           <a:p>
             <a:r>
-              <a:t>Step 1 · 6:00–6:06 · Opening Talk.</a:t>
-            </a:r>
-          </a:p>
-          <a:p>
-            <a:r>
-              <a:t>Work with a partner.</a:t>
-            </a:r>
-          </a:p>
-          <a:p>
-            <a:r>
-              <a:t>Lesson plan: Step 1; Opening Talk page.</a:t>
-            </a:r>
-          </a:p>
-          <a:p>
-            <a:r>
-              <a:t>Picture: Twemoji graphics by Twitter, Inc. and other contributors (https://github.com/jdecked/twemoji), CC BY 4.0 (https://creativecommons.org/licenses/by/4.0/); resized and combined, with signs and labels (images/CREDITS.md).</a:t>
+              <a:t>Click to circle each answer: 1 was added • 2 was received • 3 posted the payment • 4 by the phone company • 5 Yes, they are • 6 No, it wasn't</a:t>
+            </a:r>
+          </a:p>
+          <a:p>
+            <a:r>
+              <a:t>Lesson plan: Step 4; Grammar Practice B; Answer key.</a:t>
             </a:r>
           </a:p>
         </p:txBody>
@@ -2041,7 +1931,7 @@
 </p:notes>
 </file>
 
-<file path=ppt/notesSlides/notesSlide3.xml><?xml version="1.0" encoding="utf-8"?>
+<file path=ppt/notesSlides/notesSlide45.xml><?xml version="1.0" encoding="utf-8"?>
 <p:notes xmlns:a="http://schemas.openxmlformats.org/drawingml/2006/main" xmlns:p="http://schemas.openxmlformats.org/presentationml/2006/main" xmlns:r="http://schemas.openxmlformats.org/officeDocument/2006/relationships">
   <p:cSld>
     <p:spTree>
@@ -2086,17 +1976,17 @@
           <a:lstStyle/>
           <a:p>
             <a:r>
-              <a:t>Step 6 · 7:18–7:25 · Read &amp; Write.</a:t>
-            </a:r>
-          </a:p>
-          <a:p>
-            <a:r>
-              <a:t>Click to show each answer: 1 On Tuesday • 2 On Friday • 3 $6 • 4 Money back • 5 $0</a:t>
-            </a:r>
-          </a:p>
-          <a:p>
-            <a:r>
-              <a:t>Lesson plan: Step 6; Read &amp; Write page; Answer key.</a:t>
+              <a:t>Read Don't say, then Say. Learners try first. Then click.</a:t>
+            </a:r>
+          </a:p>
+          <a:p>
+            <a:r>
+              <a:t>Lesson plan: Grammar: Common mistakes.</a:t>
+            </a:r>
+          </a:p>
+          <a:p>
+            <a:r>
+              <a:t>Picture: Twemoji graphics by Twitter, Inc. and other contributors (https://github.com/jdecked/twemoji), CC BY 4.0 (https://creativecommons.org/licenses/by/4.0/); resized and combined, with signs and labels (images/CREDITS.md).</a:t>
             </a:r>
           </a:p>
         </p:txBody>
@@ -2121,7 +2011,7 @@
 </p:notes>
 </file>
 
-<file path=ppt/notesSlides/notesSlide30.xml><?xml version="1.0" encoding="utf-8"?>
+<file path=ppt/notesSlides/notesSlide46.xml><?xml version="1.0" encoding="utf-8"?>
 <p:notes xmlns:a="http://schemas.openxmlformats.org/drawingml/2006/main" xmlns:p="http://schemas.openxmlformats.org/presentationml/2006/main" xmlns:r="http://schemas.openxmlformats.org/officeDocument/2006/relationships">
   <p:cSld>
     <p:spTree>
@@ -2166,17 +2056,22 @@
           <a:lstStyle/>
           <a:p>
             <a:r>
-              <a:t>Each click shows the next card.</a:t>
-            </a:r>
-          </a:p>
-          <a:p>
-            <a:r>
-              <a:t>A asks. B answers. Then switch.</a:t>
-            </a:r>
-          </a:p>
-          <a:p>
-            <a:r>
-              <a:t>Lesson plan: Step 1; Opening Talk page.</a:t>
+              <a:t>A says a line from the statement. B says it again with was or were and a participle. Then switch. ---</a:t>
+            </a:r>
+          </a:p>
+          <a:p>
+            <a:r>
+              <a:t>Break · 6:45–7:00.</a:t>
+            </a:r>
+          </a:p>
+          <a:p>
+            <a:r>
+              <a:t>Lesson plan: Step 4: Pair check.</a:t>
+            </a:r>
+          </a:p>
+          <a:p>
+            <a:r>
+              <a:t>Picture: Twemoji graphics by Twitter, Inc. and other contributors (https://github.com/jdecked/twemoji), CC BY 4.0 (https://creativecommons.org/licenses/by/4.0/); resized and combined, with signs and labels (images/CREDITS.md).</a:t>
             </a:r>
           </a:p>
         </p:txBody>
@@ -2201,7 +2096,7 @@
 </p:notes>
 </file>
 
-<file path=ppt/notesSlides/notesSlide4.xml><?xml version="1.0" encoding="utf-8"?>
+<file path=ppt/notesSlides/notesSlide47.xml><?xml version="1.0" encoding="utf-8"?>
 <p:notes xmlns:a="http://schemas.openxmlformats.org/drawingml/2006/main" xmlns:p="http://schemas.openxmlformats.org/presentationml/2006/main" xmlns:r="http://schemas.openxmlformats.org/officeDocument/2006/relationships">
   <p:cSld>
     <p:spTree>
@@ -2246,7 +2141,7 @@
           <a:lstStyle/>
           <a:p>
             <a:r>
-              <a:t>Round 2.</a:t>
+              <a:t>Round 1.</a:t>
             </a:r>
           </a:p>
           <a:p>
@@ -2281,7 +2176,7 @@
 </p:notes>
 </file>
 
-<file path=ppt/notesSlides/notesSlide5.xml><?xml version="1.0" encoding="utf-8"?>
+<file path=ppt/notesSlides/notesSlide48.xml><?xml version="1.0" encoding="utf-8"?>
 <p:notes xmlns:a="http://schemas.openxmlformats.org/drawingml/2006/main" xmlns:p="http://schemas.openxmlformats.org/presentationml/2006/main" xmlns:r="http://schemas.openxmlformats.org/officeDocument/2006/relationships">
   <p:cSld>
     <p:spTree>
@@ -2326,7 +2221,7 @@
           <a:lstStyle/>
           <a:p>
             <a:r>
-              <a:t>Round 1.</a:t>
+              <a:t>Round 2.</a:t>
             </a:r>
           </a:p>
           <a:p>
@@ -2361,7 +2256,7 @@
 </p:notes>
 </file>
 
-<file path=ppt/notesSlides/notesSlide51.xml><?xml version="1.0" encoding="utf-8"?>
+<file path=ppt/notesSlides/notesSlide49.xml><?xml version="1.0" encoding="utf-8"?>
 <p:notes xmlns:a="http://schemas.openxmlformats.org/drawingml/2006/main" xmlns:p="http://schemas.openxmlformats.org/presentationml/2006/main" xmlns:r="http://schemas.openxmlformats.org/officeDocument/2006/relationships">
   <p:cSld>
     <p:spTree>
@@ -2406,22 +2301,17 @@
           <a:lstStyle/>
           <a:p>
             <a:r>
-              <a:t>Read the three Now you can lines.</a:t>
-            </a:r>
-          </a:p>
-          <a:p>
-            <a:r>
-              <a:t>Homework is about 20–25 minutes. Bring it next week.</a:t>
-            </a:r>
-          </a:p>
-          <a:p>
-            <a:r>
-              <a:t>Lesson plan: At a glance: Objectives; Step 7.</a:t>
-            </a:r>
-          </a:p>
-          <a:p>
-            <a:r>
-              <a:t>Picture: Twemoji graphics by Twitter, Inc. and other contributors (https://github.com/jdecked/twemoji), CC BY 4.0 (https://creativecommons.org/licenses/by/4.0/); resized and combined, with signs and labels (images/CREDITS.md).</a:t>
+              <a:t>Step 6 · 7:18–7:25 · Read &amp; Write.</a:t>
+            </a:r>
+          </a:p>
+          <a:p>
+            <a:r>
+              <a:t>Click to show each answer: 1 On Tuesday • 2 On Friday • 3 $6 • 4 Money back • 5 $0</a:t>
+            </a:r>
+          </a:p>
+          <a:p>
+            <a:r>
+              <a:t>Lesson plan: Step 6; Read &amp; Write page; Answer key.</a:t>
             </a:r>
           </a:p>
         </p:txBody>
@@ -2446,7 +2336,7 @@
 </p:notes>
 </file>
 
-<file path=ppt/notesSlides/notesSlide6.xml><?xml version="1.0" encoding="utf-8"?>
+<file path=ppt/notesSlides/notesSlide50.xml><?xml version="1.0" encoding="utf-8"?>
 <p:notes xmlns:a="http://schemas.openxmlformats.org/drawingml/2006/main" xmlns:p="http://schemas.openxmlformats.org/presentationml/2006/main" xmlns:r="http://schemas.openxmlformats.org/officeDocument/2006/relationships">
   <p:cSld>
     <p:spTree>
@@ -2491,17 +2381,17 @@
           <a:lstStyle/>
           <a:p>
             <a:r>
-              <a:t>A says a line from the statement. B says it again with was or were and a participle. Then switch. ---</a:t>
-            </a:r>
-          </a:p>
-          <a:p>
-            <a:r>
-              <a:t>Break · 6:45–7:00.</a:t>
-            </a:r>
-          </a:p>
-          <a:p>
-            <a:r>
-              <a:t>Lesson plan: Step 4: Pair check.</a:t>
+              <a:t>Step 7 · 7:25–7:30 · Exit ticket and homework. Never skip the exit ticket.</a:t>
+            </a:r>
+          </a:p>
+          <a:p>
+            <a:r>
+              <a:t>Explain one line from a statement.</a:t>
+            </a:r>
+          </a:p>
+          <a:p>
+            <a:r>
+              <a:t>Lesson plan: Step 7; Exit Ticket page; Homework page.</a:t>
             </a:r>
           </a:p>
           <a:p>
@@ -2531,7 +2421,7 @@
 </p:notes>
 </file>
 
-<file path=ppt/notesSlides/notesSlide7.xml><?xml version="1.0" encoding="utf-8"?>
+<file path=ppt/notesSlides/notesSlide52.xml><?xml version="1.0" encoding="utf-8"?>
 <p:notes xmlns:a="http://schemas.openxmlformats.org/drawingml/2006/main" xmlns:p="http://schemas.openxmlformats.org/presentationml/2006/main" xmlns:r="http://schemas.openxmlformats.org/officeDocument/2006/relationships">
   <p:cSld>
     <p:spTree>
@@ -2576,17 +2466,27 @@
           <a:lstStyle/>
           <a:p>
             <a:r>
-              <a:t>Read Don't say, then Say. Learners try first. Then click.</a:t>
-            </a:r>
-          </a:p>
-          <a:p>
-            <a:r>
-              <a:t>Lesson plan: Grammar: Common mistakes.</a:t>
-            </a:r>
-          </a:p>
-          <a:p>
-            <a:r>
-              <a:t>Picture: Twemoji graphics by Twitter, Inc. and other contributors (https://github.com/jdecked/twemoji), CC BY 4.0 (https://creativecommons.org/licenses/by/4.0/); resized and combined, with signs and labels (images/CREDITS.md).</a:t>
+              <a:t>Credits. You don't need to read this slide in class.</a:t>
+            </a:r>
+          </a:p>
+          <a:p>
+            <a:r>
+              <a:t>Pictures: Twemoji graphics by Twitter, Inc. and other contributors, CC BY 4.0; the file-by-file list is in images/CREDITS.md.</a:t>
+            </a:r>
+          </a:p>
+          <a:p>
+            <a:r>
+              <a:t>Audio: synthetic voices, computer-generated (Chatterbox TTS cloned from Kokoro-82M reference clips). No recordings of real people. The names and the story are invented.</a:t>
+            </a:r>
+          </a:p>
+          <a:p>
+            <a:r>
+              <a:t>Course materials: © 2026 the authors, licensed under CC BY-NC-SA 4.0 (https://creativecommons.org/licenses/by-nc-sa/4.0/).</a:t>
+            </a:r>
+          </a:p>
+          <a:p>
+            <a:r>
+              <a:t>Lesson plan: Picture Credits. Picture list: images/CREDITS.md.</a:t>
             </a:r>
           </a:p>
         </p:txBody>
@@ -2611,7 +2511,7 @@
 </p:notes>
 </file>
 
-<file path=ppt/notesSlides/notesSlide9.xml><?xml version="1.0" encoding="utf-8"?>
+<file path=ppt/notesSlides/notesSlide8.xml><?xml version="1.0" encoding="utf-8"?>
 <p:notes xmlns:a="http://schemas.openxmlformats.org/drawingml/2006/main" xmlns:p="http://schemas.openxmlformats.org/presentationml/2006/main" xmlns:r="http://schemas.openxmlformats.org/officeDocument/2006/relationships">
   <p:cSld>
     <p:spTree>
@@ -2656,12 +2556,22 @@
           <a:lstStyle/>
           <a:p>
             <a:r>
-              <a:t>Click to circle each answer: 1 was added • 2 was received • 3 posted the payment • 4 by the phone company • 5 Yes, they are • 6 No, it wasn't</a:t>
-            </a:r>
-          </a:p>
-          <a:p>
-            <a:r>
-              <a:t>Lesson plan: Step 4; Grammar Practice B; Answer key.</a:t>
+              <a:t>Read the three Now you can lines.</a:t>
+            </a:r>
+          </a:p>
+          <a:p>
+            <a:r>
+              <a:t>Homework is about 20–25 minutes. Bring it next week.</a:t>
+            </a:r>
+          </a:p>
+          <a:p>
+            <a:r>
+              <a:t>Lesson plan: At a glance: Objectives; Step 7.</a:t>
+            </a:r>
+          </a:p>
+          <a:p>
+            <a:r>
+              <a:t>Picture: Twemoji graphics by Twitter, Inc. and other contributors (https://github.com/jdecked/twemoji), CC BY 4.0 (https://creativecommons.org/licenses/by/4.0/); resized and combined, with signs and labels (images/CREDITS.md).</a:t>
             </a:r>
           </a:p>
         </p:txBody>
@@ -5231,9 +5141,9 @@
               <a:buNone/>
             </a:pPr>
             <a:r>
-              <a:rPr lang="en-US" sz="1800" dirty="0" b="0">
-                <a:solidFill>
-                  <a:srgbClr val="1B2236"/>
+              <a:rPr lang="en-US" sz="1800" dirty="0" b="1">
+                <a:solidFill>
+                  <a:srgbClr val="5B3FC4"/>
                 </a:solidFill>
                 <a:latin typeface="Lexend Deca" pitchFamily="34" charset="0"/>
                 <a:ea typeface="Lexend Deca" pitchFamily="34" charset="-122"/>
@@ -5241,7 +5151,7 @@
               </a:rPr>
               <a:t>your note.</a:t>
             </a:r>
-            <a:endParaRPr lang="en-US" sz="1800" dirty="0" b="0"/>
+            <a:endParaRPr lang="en-US" sz="1800" dirty="0" b="1"/>
           </a:p>
         </p:txBody>
       </p:sp>
@@ -10989,7 +10899,7 @@
                 <a:ea typeface="Lexend Deca" pitchFamily="34" charset="-122"/>
                 <a:cs typeface="Lexend Deca" pitchFamily="34" charset="-120"/>
               </a:rPr>
-              <a:t>Audio (about 2:20): coming soon.</a:t>
+              <a:t>Audio: about 1:43. It plays once.</a:t>
             </a:r>
             <a:endParaRPr lang="en-US" sz="2200" dirty="0"/>
           </a:p>
@@ -29110,7 +29020,7 @@
                 <a:ea typeface="Lexend Deca" pitchFamily="34" charset="-122"/>
                 <a:cs typeface="Lexend Deca" pitchFamily="34" charset="-120"/>
               </a:rPr>
-              <a:t>Audio (coming soon): synthetic voices made with Chatterbox TTS (MIT License), cloned from short synthetic reference clips made with Kokoro-82M (Apache License 2.0). No recordings of real people. Each file will carry an inaudible Perth watermark marking it as AI-generated. Font: Lexend Deca (OFL 1.1).</a:t>
+              <a:t>Audio: synthetic voices made with Chatterbox TTS (MIT License), cloned from short synthetic reference clips made with Kokoro-82M (Apache License 2.0). No recordings of real people were used. Each file carries an inaudible Perth watermark marking it as AI-generated. Font: Lexend Deca (OFL 1.1).</a:t>
             </a:r>
             <a:endParaRPr lang="en-US" sz="1350" dirty="0" b="0"/>
           </a:p>

</xml_diff>